<commit_message>
Presentation: add Class 3A, dry-run, corrected meal signup date
- Class 3A now on title and schedule slides
- Dry-run added: June 20, 9:00 AM, Clearwater Fire Training Center
- Meal signup deadline corrected: June 22 at 11:59 PM (was June 20)
- Schedule slide reordered: location first, dates with explicit times next
- build-presentation.py committed so the deck can be regenerated by anyone
  running 'python3 site-setup/build-presentation.py'
</commit_message>
<xml_diff>
--- a/site-setup/2026-field-day-presentation.pptx
+++ b/site-setup/2026-field-day-presentation.pptx
@@ -3144,7 +3144,7 @@
           <a:lstStyle/>
           <a:p>
             <a:r>
-              <a:t>UPARC · SPARC · WORMs · CARS  —  Contest Callsign W4TA</a:t>
+              <a:t>UPARC · SPARC · WORMs · CARS  —  Contest Callsign W4TA  —  Class 3A</a:t>
             </a:r>
           </a:p>
         </p:txBody>
@@ -3479,6 +3479,12 @@
               <a:t>If you have special dietary needs, please plan to provide for yourself.</a:t>
             </a:r>
           </a:p>
+          <a:p>
+            <a:pPr/>
+            <a:r>
+              <a:t>Meal signup: www.uparc.org — by June 22 at 11:59 PM.</a:t>
+            </a:r>
+          </a:p>
         </p:txBody>
       </p:sp>
     </p:spTree>
@@ -3548,7 +3554,13 @@
           <a:p>
             <a:pPr/>
             <a:r>
-              <a:t>Club members: sign up at www.uparc.org no later than June 20.</a:t>
+              <a:t>Club members: meal signup at www.uparc.org no later than June 22 at 11:59 PM.</a:t>
+            </a:r>
+          </a:p>
+          <a:p>
+            <a:pPr/>
+            <a:r>
+              <a:t>Dry-run / shakedown: Saturday June 20, 9:00 AM, Clearwater Fire Training Center — open to all members.</a:t>
             </a:r>
           </a:p>
           <a:p>
@@ -3566,7 +3578,7 @@
           <a:p>
             <a:pPr/>
             <a:r>
-              <a:t>Volunteer for setup (Sat 8 AM) or teardown (Sun 2 PM) to learn the gear.</a:t>
+              <a:t>Volunteer for setup (Sat June 27, 8 AM) or teardown (Sun June 28, 2 PM) to learn the gear.</a:t>
             </a:r>
           </a:p>
         </p:txBody>
@@ -3650,7 +3662,7 @@
           <a:p>
             <a:pPr/>
             <a:r>
-              <a:t>If something is wrong with your rig or laptop, retrace the setup card on your table before calling LAN team.</a:t>
+              <a:t>If something is wrong with your rig or laptop, retrace the setup card on your table before calling the LAN team.</a:t>
             </a:r>
           </a:p>
           <a:p>
@@ -3989,49 +4001,61 @@
           <a:p>
             <a:pPr/>
             <a:r>
+              <a:t>Where: Clearwater Fire Station #48</a:t>
+            </a:r>
+          </a:p>
+          <a:p>
+            <a:pPr lvl="1"/>
+            <a:r>
+              <a:t>1700 N Belcher Rd., Clearwater, FL 33765</a:t>
+            </a:r>
+          </a:p>
+          <a:p>
+            <a:pPr/>
+            <a:r>
               <a:t>When: June 27–28, 2026 (Saturday – Sunday)</a:t>
             </a:r>
           </a:p>
           <a:p>
-            <a:pPr/>
-            <a:r>
-              <a:t>Where: Clearwater Fire Station #48</a:t>
-            </a:r>
-          </a:p>
-          <a:p>
             <a:pPr lvl="1"/>
             <a:r>
-              <a:t>1700 N Belcher Rd., Clearwater, FL 33765</a:t>
-            </a:r>
-          </a:p>
-          <a:p>
-            <a:pPr/>
-            <a:r>
-              <a:t>Setup: 8 AM Saturday (lunch around noon)</a:t>
-            </a:r>
-          </a:p>
-          <a:p>
-            <a:pPr/>
-            <a:r>
-              <a:t>Operate: 2 PM Saturday → 2 PM Sunday</a:t>
-            </a:r>
-          </a:p>
-          <a:p>
-            <a:pPr/>
-            <a:r>
-              <a:t>Teardown: 2 PM Sunday onward</a:t>
-            </a:r>
-          </a:p>
-          <a:p>
-            <a:pPr/>
-            <a:r>
-              <a:t>Operation is indoors (except Satellite station).</a:t>
-            </a:r>
-          </a:p>
-          <a:p>
-            <a:pPr/>
-            <a:r>
-              <a:t>Signup at www.uparc.org — please by June 20.</a:t>
+              <a:t>Setup begins: 8:00 AM Saturday, June 27 (lunch around noon)</a:t>
+            </a:r>
+          </a:p>
+          <a:p>
+            <a:pPr lvl="1"/>
+            <a:r>
+              <a:t>Operating begins: 2:00 PM Saturday, June 27</a:t>
+            </a:r>
+          </a:p>
+          <a:p>
+            <a:pPr lvl="1"/>
+            <a:r>
+              <a:t>Operating ends / teardown: 2:00 PM Sunday, June 28</a:t>
+            </a:r>
+          </a:p>
+          <a:p>
+            <a:pPr/>
+            <a:r>
+              <a:t>ARRL Class: 3A  (three simultaneous transmitters, portable/club)</a:t>
+            </a:r>
+          </a:p>
+          <a:p>
+            <a:pPr/>
+            <a:r>
+              <a:t>Operation is indoors (except the Satellite station).</a:t>
+            </a:r>
+          </a:p>
+          <a:p>
+            <a:pPr/>
+            <a:r>
+              <a:t>Dry-run: Saturday June 20, 9:00 AM, Clearwater Fire Training Center</a:t>
+            </a:r>
+          </a:p>
+          <a:p>
+            <a:pPr/>
+            <a:r>
+              <a:t>Meal signup: www.uparc.org — by June 22 at 11:59 PM</a:t>
             </a:r>
           </a:p>
         </p:txBody>

</xml_diff>

<commit_message>
Presentation: rewrite to 7x7 rule (23 slides) + structural fix
Per feedback, slides were overflowing because bullets ran 15+ words. Each
bullet now ~5-7 words; dense content split across more slides. Slide count:
15 → 23.

Splits:
- Stations: one slide each (K4 / K3S / K3-CW / VHF / Satellite)
- Schedule split out from When & Where
- Logging Network split into Overview + Pi 400 Services
- Meals split into Saturday / Sunday / Meal Signup
- Visitors and Members get their own slides

Structural fix: refactored add_bullets() to avoid text_frame.clear() and
instead overwrite the first paragraph in place. text_frame.clear() has
historically produced files PowerPoint flags for repair in some cases.

Validation: round-trip parse by python-pptx clean (0 empty paragraphs);
slide XML well-formed; zip structure has all 23 slides plus rels.
</commit_message>
<xml_diff>
--- a/site-setup/2026-field-day-presentation.pptx
+++ b/site-setup/2026-field-day-presentation.pptx
@@ -20,6 +20,14 @@
     <p:sldId id="268" r:id="rId19"/>
     <p:sldId id="269" r:id="rId20"/>
     <p:sldId id="270" r:id="rId21"/>
+    <p:sldId id="271" r:id="rId22"/>
+    <p:sldId id="272" r:id="rId23"/>
+    <p:sldId id="273" r:id="rId24"/>
+    <p:sldId id="274" r:id="rId25"/>
+    <p:sldId id="275" r:id="rId26"/>
+    <p:sldId id="276" r:id="rId27"/>
+    <p:sldId id="277" r:id="rId28"/>
+    <p:sldId id="278" r:id="rId29"/>
   </p:sldIdLst>
   <p:sldSz cx="12191695" cy="6858000" type="screen4x3"/>
   <p:notesSz cx="6858000" cy="9144000"/>
@@ -3144,7 +3152,7 @@
           <a:lstStyle/>
           <a:p>
             <a:r>
-              <a:t>UPARC · SPARC · WORMs · CARS  —  Contest Callsign W4TA  —  Class 3A</a:t>
+              <a:t>UPARC · SPARC · WORMs · CARS  —  W4TA  —  Class 3A</a:t>
             </a:r>
           </a:p>
         </p:txBody>
@@ -3212,7 +3220,7 @@
                   <a:srgbClr val="1F4E79"/>
                 </a:solidFill>
               </a:rPr>
-              <a:t>Satellite Station</a:t>
+              <a:t>Station 3 — Elecraft K3 (CW)</a:t>
             </a:r>
           </a:p>
         </p:txBody>
@@ -3234,31 +3242,31 @@
           <a:p>
             <a:pPr/>
             <a:r>
-              <a:t>ICOM IC-9700 transceiver</a:t>
-            </a:r>
-          </a:p>
-          <a:p>
-            <a:pPr/>
-            <a:r>
-              <a:t>Yaesu AZ/EL rotator</a:t>
-            </a:r>
-          </a:p>
-          <a:p>
-            <a:pPr/>
-            <a:r>
-              <a:t>Arrow yagi antenna</a:t>
-            </a:r>
-          </a:p>
-          <a:p>
-            <a:pPr/>
-            <a:r>
-              <a:t>Satellite control / tracking device</a:t>
-            </a:r>
-          </a:p>
-          <a:p>
-            <a:pPr/>
-            <a:r>
-              <a:t>Operated outdoors (only station not in the radio room).</a:t>
+              <a:t>Primary mode: CW</a:t>
+            </a:r>
+          </a:p>
+          <a:p>
+            <a:pPr/>
+            <a:r>
+              <a:t>WinKey Mini + Bencher paddle</a:t>
+            </a:r>
+          </a:p>
+          <a:p>
+            <a:pPr/>
+            <a:r>
+              <a:t>Paddle supplied by NY4I</a:t>
+            </a:r>
+          </a:p>
+          <a:p>
+            <a:pPr/>
+            <a:r>
+              <a:t>Coax: 65 ft RG-8X around room</a:t>
+            </a:r>
+          </a:p>
+          <a:p>
+            <a:pPr/>
+            <a:r>
+              <a:t>Also runs SSB and Digital</a:t>
             </a:r>
           </a:p>
         </p:txBody>
@@ -3302,7 +3310,7 @@
                   <a:srgbClr val="1F4E79"/>
                 </a:solidFill>
               </a:rPr>
-              <a:t>Education &amp; Training Sessions</a:t>
+              <a:t>VHF Station — Yaesu FT-897</a:t>
             </a:r>
           </a:p>
         </p:txBody>
@@ -3322,49 +3330,27 @@
           <a:bodyPr/>
           <a:lstStyle/>
           <a:p>
-            <a:r>
-              <a:rPr i="1" sz="1600">
-                <a:solidFill>
-                  <a:srgbClr val="555555"/>
-                </a:solidFill>
-              </a:rPr>
-              <a:t>Fred W2SUB</a:t>
-            </a:r>
-          </a:p>
-          <a:p>
-            <a:pPr/>
-            <a:r>
-              <a:t>Welcome to Field Day — for all visitors</a:t>
-            </a:r>
-          </a:p>
-          <a:p>
-            <a:pPr/>
-            <a:r>
-              <a:t>Ham Radio Basics</a:t>
-            </a:r>
-          </a:p>
-          <a:p>
-            <a:pPr/>
-            <a:r>
-              <a:t>Ham Radio Awards &amp; Achievements</a:t>
-            </a:r>
-          </a:p>
-          <a:p>
-            <a:pPr/>
-            <a:r>
-              <a:t>How to build an EFHW kit antenna</a:t>
-            </a:r>
-          </a:p>
-          <a:p>
-            <a:pPr/>
-            <a:r>
-              <a:t>How to use an Antenna Analyzer</a:t>
-            </a:r>
-          </a:p>
-          <a:p>
-            <a:pPr/>
-            <a:r>
-              <a:t>All sessions led by Fred W2SUB.</a:t>
+            <a:pPr/>
+            <a:r>
+              <a:t>Band: 6 m</a:t>
+            </a:r>
+          </a:p>
+          <a:p>
+            <a:pPr/>
+            <a:r>
+              <a:t>Brought by Paul KC4YDY</a:t>
+            </a:r>
+          </a:p>
+          <a:p>
+            <a:pPr/>
+            <a:r>
+              <a:t>Hand mic only (no Heil)</a:t>
+            </a:r>
+          </a:p>
+          <a:p>
+            <a:pPr/>
+            <a:r>
+              <a:t>Owns its own setup / power</a:t>
             </a:r>
           </a:p>
         </p:txBody>
@@ -3408,7 +3394,7 @@
                   <a:srgbClr val="1F4E79"/>
                 </a:solidFill>
               </a:rPr>
-              <a:t>Hospitality (a.k.a. Food)</a:t>
+              <a:t>Satellite Station</a:t>
             </a:r>
           </a:p>
         </p:txBody>
@@ -3428,61 +3414,33 @@
           <a:bodyPr/>
           <a:lstStyle/>
           <a:p>
-            <a:r>
-              <a:rPr i="1" sz="1600">
-                <a:solidFill>
-                  <a:srgbClr val="555555"/>
-                </a:solidFill>
-              </a:rPr>
-              <a:t>Ron W4RFA</a:t>
-            </a:r>
-          </a:p>
-          <a:p>
-            <a:pPr/>
-            <a:r>
-              <a:t>Saturday breakfast: donuts, coffee</a:t>
-            </a:r>
-          </a:p>
-          <a:p>
-            <a:pPr/>
-            <a:r>
-              <a:t>Saturday lunch: hamburgers, hotdogs, salad, chips</a:t>
-            </a:r>
-          </a:p>
-          <a:p>
-            <a:pPr/>
-            <a:r>
-              <a:t>Saturday dinner: TBD — bring a side dish to share</a:t>
-            </a:r>
-          </a:p>
-          <a:p>
-            <a:pPr/>
-            <a:r>
-              <a:t>Sunday breakfast: bagels (Tom), coffee</a:t>
-            </a:r>
-          </a:p>
-          <a:p>
-            <a:pPr/>
-            <a:r>
-              <a:t>Sunday lunch: leftovers</a:t>
-            </a:r>
-          </a:p>
-          <a:p>
-            <a:pPr/>
-            <a:r>
-              <a:t>Water, tea and sodas provided throughout the event.</a:t>
-            </a:r>
-          </a:p>
-          <a:p>
-            <a:pPr/>
-            <a:r>
-              <a:t>If you have special dietary needs, please plan to provide for yourself.</a:t>
-            </a:r>
-          </a:p>
-          <a:p>
-            <a:pPr/>
-            <a:r>
-              <a:t>Meal signup: www.uparc.org — by June 22 at 11:59 PM.</a:t>
+            <a:pPr/>
+            <a:r>
+              <a:t>ICOM IC-9700 transceiver</a:t>
+            </a:r>
+          </a:p>
+          <a:p>
+            <a:pPr/>
+            <a:r>
+              <a:t>Yaesu AZ/EL rotator</a:t>
+            </a:r>
+          </a:p>
+          <a:p>
+            <a:pPr/>
+            <a:r>
+              <a:t>Arrow yagi antenna</a:t>
+            </a:r>
+          </a:p>
+          <a:p>
+            <a:pPr/>
+            <a:r>
+              <a:t>Tracking / control device</a:t>
+            </a:r>
+          </a:p>
+          <a:p>
+            <a:pPr/>
+            <a:r>
+              <a:t>Operated outdoors</a:t>
             </a:r>
           </a:p>
         </p:txBody>
@@ -3526,7 +3484,7 @@
                   <a:srgbClr val="1F4E79"/>
                 </a:solidFill>
               </a:rPr>
-              <a:t>Visitors &amp; How to Get Involved</a:t>
+              <a:t>Logging Network — Overview</a:t>
             </a:r>
           </a:p>
         </p:txBody>
@@ -3548,37 +3506,48 @@
           <a:p>
             <a:pPr/>
             <a:r>
-              <a:t>Visitors are very welcome — Field Day is a public outreach event.</a:t>
-            </a:r>
-          </a:p>
-          <a:p>
-            <a:pPr/>
-            <a:r>
-              <a:t>Club members: meal signup at www.uparc.org no later than June 22 at 11:59 PM.</a:t>
-            </a:r>
-          </a:p>
-          <a:p>
-            <a:pPr/>
-            <a:r>
-              <a:t>Dry-run / shakedown: Saturday June 20, 9:00 AM, Clearwater Fire Training Center — open to all members.</a:t>
-            </a:r>
-          </a:p>
-          <a:p>
-            <a:pPr/>
-            <a:r>
-              <a:t>Bring your own wired headset (3.5 mm or 1/4 in plug).</a:t>
-            </a:r>
-          </a:p>
-          <a:p>
-            <a:pPr/>
-            <a:r>
-              <a:t>If you’ve never operated a contest before — we’ll partner you with an experienced op.</a:t>
-            </a:r>
-          </a:p>
-          <a:p>
-            <a:pPr/>
-            <a:r>
-              <a:t>Volunteer for setup (Sat June 27, 8 AM) or teardown (Sun June 28, 2 PM) to learn the gear.</a:t>
+              <a:rPr i="1" sz="1600">
+                <a:solidFill>
+                  <a:srgbClr val="555555"/>
+                </a:solidFill>
+              </a:rPr>
+              <a:t>Tom NY4I</a:t>
+            </a:r>
+          </a:p>
+          <a:p>
+            <a:pPr/>
+            <a:r>
+              <a:t>All HF laptops run TR4W</a:t>
+            </a:r>
+          </a:p>
+          <a:p>
+            <a:pPr/>
+            <a:r>
+              <a:t>Laptops on TRLOG WiFi (10.0.0/24)</a:t>
+            </a:r>
+          </a:p>
+          <a:p>
+            <a:pPr/>
+            <a:r>
+              <a:t>Pi 400 is the server</a:t>
+            </a:r>
+          </a:p>
+          <a:p>
+            <a:pPr/>
+            <a:r>
+              <a:t>Pi 400 wired to Linksys router</a:t>
+            </a:r>
+          </a:p>
+          <a:p>
+            <a:pPr/>
+            <a:r>
+              <a:t>Pi 400 address: 192.168.0.100</a:t>
+            </a:r>
+          </a:p>
+          <a:p>
+            <a:pPr/>
+            <a:r>
+              <a:t>UPS protects Pi + router</a:t>
             </a:r>
           </a:p>
         </p:txBody>
@@ -3622,7 +3591,7 @@
                   <a:srgbClr val="1F4E79"/>
                 </a:solidFill>
               </a:rPr>
-              <a:t>Operating Etiquette — Quick Reference</a:t>
+              <a:t>Pi 400 — What it runs</a:t>
             </a:r>
           </a:p>
         </p:txBody>
@@ -3644,31 +3613,48 @@
           <a:p>
             <a:pPr/>
             <a:r>
-              <a:t>Don’t forget to “OPON” when starting your shift (TR4W operator change).</a:t>
-            </a:r>
-          </a:p>
-          <a:p>
-            <a:pPr/>
-            <a:r>
-              <a:t>Confirm the band/mode is open before calling — listen first.</a:t>
-            </a:r>
-          </a:p>
-          <a:p>
-            <a:pPr/>
-            <a:r>
-              <a:t>Log every QSO immediately; the stats screen updates from your log.</a:t>
-            </a:r>
-          </a:p>
-          <a:p>
-            <a:pPr/>
-            <a:r>
-              <a:t>If something is wrong with your rig or laptop, retrace the setup card on your table before calling the LAN team.</a:t>
-            </a:r>
-          </a:p>
-          <a:p>
-            <a:pPr/>
-            <a:r>
-              <a:t>Have fun — it’s a contest, not an exam.</a:t>
+              <a:rPr i="1" sz="1600">
+                <a:solidFill>
+                  <a:srgbClr val="555555"/>
+                </a:solidFill>
+              </a:rPr>
+              <a:t>Tom NY4I</a:t>
+            </a:r>
+          </a:p>
+          <a:p>
+            <a:pPr/>
+            <a:r>
+              <a:t>TR4W Server (Python)</a:t>
+            </a:r>
+          </a:p>
+          <a:p>
+            <a:pPr/>
+            <a:r>
+              <a:t>NTP — laptop time sync</a:t>
+            </a:r>
+          </a:p>
+          <a:p>
+            <a:pPr/>
+            <a:r>
+              <a:t>n1mm_view — stats images</a:t>
+            </a:r>
+          </a:p>
+          <a:p>
+            <a:pPr/>
+            <a:r>
+              <a:t>Local web UI on :8080</a:t>
+            </a:r>
+          </a:p>
+          <a:p>
+            <a:pPr/>
+            <a:r>
+              <a:t>rsync publisher → UPARC + SPARC</a:t>
+            </a:r>
+          </a:p>
+          <a:p>
+            <a:pPr/>
+            <a:r>
+              <a:t>Replaces old Windows server box</a:t>
             </a:r>
           </a:p>
         </p:txBody>
@@ -3707,55 +3693,450 @@
           <a:lstStyle/>
           <a:p>
             <a:r>
-              <a:rPr b="1" sz="6000">
+              <a:rPr b="1">
                 <a:solidFill>
                   <a:srgbClr val="1F4E79"/>
                 </a:solidFill>
               </a:rPr>
-              <a:t>Q &amp; A</a:t>
-            </a:r>
-          </a:p>
-        </p:txBody>
-      </p:sp>
-      <p:sp>
-        <p:nvSpPr>
-          <p:cNvPr id="3" name="TextBox 2"/>
-          <p:cNvSpPr txBox="1"/>
-          <p:nvPr/>
-        </p:nvSpPr>
-        <p:spPr>
-          <a:xfrm>
-            <a:off x="914400" y="3657600"/>
-            <a:ext cx="10360152" cy="1828800"/>
-          </a:xfrm>
-          <a:prstGeom prst="rect">
-            <a:avLst/>
-          </a:prstGeom>
-          <a:noFill/>
-        </p:spPr>
-        <p:txBody>
-          <a:bodyPr wrap="none">
-            <a:spAutoFit/>
-          </a:bodyPr>
-          <a:lstStyle/>
-          <a:p>
-            <a:r>
-              <a:rPr i="1" sz="2800">
+              <a:t>Antennas &amp; Patch Panel</a:t>
+            </a:r>
+          </a:p>
+        </p:txBody>
+      </p:sp>
+      <p:sp>
+        <p:nvSpPr>
+          <p:cNvPr id="3" name="Content Placeholder 2"/>
+          <p:cNvSpPr>
+            <a:spLocks noGrp="1"/>
+          </p:cNvSpPr>
+          <p:nvPr>
+            <p:ph idx="1"/>
+          </p:nvPr>
+        </p:nvSpPr>
+        <p:spPr/>
+        <p:txBody>
+          <a:bodyPr/>
+          <a:lstStyle/>
+          <a:p>
+            <a:pPr/>
+            <a:r>
+              <a:rPr i="1" sz="1600">
                 <a:solidFill>
                   <a:srgbClr val="555555"/>
                 </a:solidFill>
               </a:rPr>
-              <a:t>Questions?  Concerns?  Volunteers?</a:t>
-            </a:r>
-          </a:p>
-          <a:p>
-            <a:r>
-              <a:rPr sz="1800">
+              <a:t>Ryan AF4O</a:t>
+            </a:r>
+          </a:p>
+          <a:p>
+            <a:pPr/>
+            <a:r>
+              <a:t>All feedlines go to patch panel</a:t>
+            </a:r>
+          </a:p>
+          <a:p>
+            <a:pPr/>
+            <a:r>
+              <a:t>Radios connect via the patch panel</a:t>
+            </a:r>
+          </a:p>
+          <a:p>
+            <a:pPr/>
+            <a:r>
+              <a:t>No coax changes without Band Boss</a:t>
+            </a:r>
+          </a:p>
+          <a:p>
+            <a:pPr/>
+            <a:r>
+              <a:t>Station 3: 65 ft RG-8X</a:t>
+            </a:r>
+          </a:p>
+          <a:p>
+            <a:pPr/>
+            <a:r>
+              <a:t>Routes east wall + top wall</a:t>
+            </a:r>
+          </a:p>
+        </p:txBody>
+      </p:sp>
+    </p:spTree>
+  </p:cSld>
+  <p:clrMapOvr>
+    <a:masterClrMapping/>
+  </p:clrMapOvr>
+</p:sld>
+</file>
+
+<file path=ppt/slides/slide16.xml><?xml version="1.0" encoding="utf-8"?>
+<p:sld xmlns:a="http://schemas.openxmlformats.org/drawingml/2006/main" xmlns:p="http://schemas.openxmlformats.org/presentationml/2006/main" xmlns:r="http://schemas.openxmlformats.org/officeDocument/2006/relationships">
+  <p:cSld>
+    <p:spTree>
+      <p:nvGrpSpPr>
+        <p:cNvPr id="1" name=""/>
+        <p:cNvGrpSpPr/>
+        <p:nvPr/>
+      </p:nvGrpSpPr>
+      <p:grpSpPr/>
+      <p:sp>
+        <p:nvSpPr>
+          <p:cNvPr id="2" name="Title 1"/>
+          <p:cNvSpPr>
+            <a:spLocks noGrp="1"/>
+          </p:cNvSpPr>
+          <p:nvPr>
+            <p:ph type="title"/>
+          </p:nvPr>
+        </p:nvSpPr>
+        <p:spPr/>
+        <p:txBody>
+          <a:bodyPr/>
+          <a:lstStyle/>
+          <a:p>
+            <a:r>
+              <a:rPr b="1">
+                <a:solidFill>
+                  <a:srgbClr val="1F4E79"/>
+                </a:solidFill>
+              </a:rPr>
+              <a:t>Education &amp; Training Sessions</a:t>
+            </a:r>
+          </a:p>
+        </p:txBody>
+      </p:sp>
+      <p:sp>
+        <p:nvSpPr>
+          <p:cNvPr id="3" name="Content Placeholder 2"/>
+          <p:cNvSpPr>
+            <a:spLocks noGrp="1"/>
+          </p:cNvSpPr>
+          <p:nvPr>
+            <p:ph idx="1"/>
+          </p:nvPr>
+        </p:nvSpPr>
+        <p:spPr/>
+        <p:txBody>
+          <a:bodyPr/>
+          <a:lstStyle/>
+          <a:p>
+            <a:pPr/>
+            <a:r>
+              <a:rPr i="1" sz="1600">
                 <a:solidFill>
                   <a:srgbClr val="555555"/>
                 </a:solidFill>
               </a:rPr>
-              <a:t>Talk to your section lead: Ryan AF4O (antennas) · Fred W2SUB (education) · Tom NY4I (logging/network) · Paul KC4YDY (VHF) · Ron W4RFA (food)</a:t>
+              <a:t>Fred W2SUB</a:t>
+            </a:r>
+          </a:p>
+          <a:p>
+            <a:pPr/>
+            <a:r>
+              <a:t>Welcome to Field Day (visitors)</a:t>
+            </a:r>
+          </a:p>
+          <a:p>
+            <a:pPr/>
+            <a:r>
+              <a:t>Ham Radio Basics</a:t>
+            </a:r>
+          </a:p>
+          <a:p>
+            <a:pPr/>
+            <a:r>
+              <a:t>Awards &amp; Achievements</a:t>
+            </a:r>
+          </a:p>
+          <a:p>
+            <a:pPr/>
+            <a:r>
+              <a:t>EFHW kit antenna build</a:t>
+            </a:r>
+          </a:p>
+          <a:p>
+            <a:pPr/>
+            <a:r>
+              <a:t>Antenna Analyzer use</a:t>
+            </a:r>
+          </a:p>
+          <a:p>
+            <a:pPr/>
+            <a:r>
+              <a:t>All sessions led by Fred W2SUB</a:t>
+            </a:r>
+          </a:p>
+        </p:txBody>
+      </p:sp>
+    </p:spTree>
+  </p:cSld>
+  <p:clrMapOvr>
+    <a:masterClrMapping/>
+  </p:clrMapOvr>
+</p:sld>
+</file>
+
+<file path=ppt/slides/slide17.xml><?xml version="1.0" encoding="utf-8"?>
+<p:sld xmlns:a="http://schemas.openxmlformats.org/drawingml/2006/main" xmlns:p="http://schemas.openxmlformats.org/presentationml/2006/main" xmlns:r="http://schemas.openxmlformats.org/officeDocument/2006/relationships">
+  <p:cSld>
+    <p:spTree>
+      <p:nvGrpSpPr>
+        <p:cNvPr id="1" name=""/>
+        <p:cNvGrpSpPr/>
+        <p:nvPr/>
+      </p:nvGrpSpPr>
+      <p:grpSpPr/>
+      <p:sp>
+        <p:nvSpPr>
+          <p:cNvPr id="2" name="Title 1"/>
+          <p:cNvSpPr>
+            <a:spLocks noGrp="1"/>
+          </p:cNvSpPr>
+          <p:nvPr>
+            <p:ph type="title"/>
+          </p:nvPr>
+        </p:nvSpPr>
+        <p:spPr/>
+        <p:txBody>
+          <a:bodyPr/>
+          <a:lstStyle/>
+          <a:p>
+            <a:r>
+              <a:rPr b="1">
+                <a:solidFill>
+                  <a:srgbClr val="1F4E79"/>
+                </a:solidFill>
+              </a:rPr>
+              <a:t>Meals — Saturday</a:t>
+            </a:r>
+          </a:p>
+        </p:txBody>
+      </p:sp>
+      <p:sp>
+        <p:nvSpPr>
+          <p:cNvPr id="3" name="Content Placeholder 2"/>
+          <p:cNvSpPr>
+            <a:spLocks noGrp="1"/>
+          </p:cNvSpPr>
+          <p:nvPr>
+            <p:ph idx="1"/>
+          </p:nvPr>
+        </p:nvSpPr>
+        <p:spPr/>
+        <p:txBody>
+          <a:bodyPr/>
+          <a:lstStyle/>
+          <a:p>
+            <a:pPr/>
+            <a:r>
+              <a:rPr i="1" sz="1600">
+                <a:solidFill>
+                  <a:srgbClr val="555555"/>
+                </a:solidFill>
+              </a:rPr>
+              <a:t>Ron W4RFA</a:t>
+            </a:r>
+          </a:p>
+          <a:p>
+            <a:pPr/>
+            <a:r>
+              <a:t>Breakfast: donuts, coffee</a:t>
+            </a:r>
+          </a:p>
+          <a:p>
+            <a:pPr/>
+            <a:r>
+              <a:t>Lunch: burgers, dogs, salad, chips</a:t>
+            </a:r>
+          </a:p>
+          <a:p>
+            <a:pPr/>
+            <a:r>
+              <a:t>Dinner: TBD</a:t>
+            </a:r>
+          </a:p>
+          <a:p>
+            <a:pPr/>
+            <a:r>
+              <a:t>Bring a side dish to share</a:t>
+            </a:r>
+          </a:p>
+        </p:txBody>
+      </p:sp>
+    </p:spTree>
+  </p:cSld>
+  <p:clrMapOvr>
+    <a:masterClrMapping/>
+  </p:clrMapOvr>
+</p:sld>
+</file>
+
+<file path=ppt/slides/slide18.xml><?xml version="1.0" encoding="utf-8"?>
+<p:sld xmlns:a="http://schemas.openxmlformats.org/drawingml/2006/main" xmlns:p="http://schemas.openxmlformats.org/presentationml/2006/main" xmlns:r="http://schemas.openxmlformats.org/officeDocument/2006/relationships">
+  <p:cSld>
+    <p:spTree>
+      <p:nvGrpSpPr>
+        <p:cNvPr id="1" name=""/>
+        <p:cNvGrpSpPr/>
+        <p:nvPr/>
+      </p:nvGrpSpPr>
+      <p:grpSpPr/>
+      <p:sp>
+        <p:nvSpPr>
+          <p:cNvPr id="2" name="Title 1"/>
+          <p:cNvSpPr>
+            <a:spLocks noGrp="1"/>
+          </p:cNvSpPr>
+          <p:nvPr>
+            <p:ph type="title"/>
+          </p:nvPr>
+        </p:nvSpPr>
+        <p:spPr/>
+        <p:txBody>
+          <a:bodyPr/>
+          <a:lstStyle/>
+          <a:p>
+            <a:r>
+              <a:rPr b="1">
+                <a:solidFill>
+                  <a:srgbClr val="1F4E79"/>
+                </a:solidFill>
+              </a:rPr>
+              <a:t>Meals — Sunday</a:t>
+            </a:r>
+          </a:p>
+        </p:txBody>
+      </p:sp>
+      <p:sp>
+        <p:nvSpPr>
+          <p:cNvPr id="3" name="Content Placeholder 2"/>
+          <p:cNvSpPr>
+            <a:spLocks noGrp="1"/>
+          </p:cNvSpPr>
+          <p:nvPr>
+            <p:ph idx="1"/>
+          </p:nvPr>
+        </p:nvSpPr>
+        <p:spPr/>
+        <p:txBody>
+          <a:bodyPr/>
+          <a:lstStyle/>
+          <a:p>
+            <a:pPr/>
+            <a:r>
+              <a:rPr i="1" sz="1600">
+                <a:solidFill>
+                  <a:srgbClr val="555555"/>
+                </a:solidFill>
+              </a:rPr>
+              <a:t>Ron W4RFA</a:t>
+            </a:r>
+          </a:p>
+          <a:p>
+            <a:pPr/>
+            <a:r>
+              <a:t>Breakfast: bagels (Tom), coffee</a:t>
+            </a:r>
+          </a:p>
+          <a:p>
+            <a:pPr/>
+            <a:r>
+              <a:t>Lunch: leftovers</a:t>
+            </a:r>
+          </a:p>
+          <a:p>
+            <a:pPr/>
+            <a:r>
+              <a:t>Water, tea, sodas all event</a:t>
+            </a:r>
+          </a:p>
+          <a:p>
+            <a:pPr/>
+            <a:r>
+              <a:t>Special diets: bring your own</a:t>
+            </a:r>
+          </a:p>
+        </p:txBody>
+      </p:sp>
+    </p:spTree>
+  </p:cSld>
+  <p:clrMapOvr>
+    <a:masterClrMapping/>
+  </p:clrMapOvr>
+</p:sld>
+</file>
+
+<file path=ppt/slides/slide19.xml><?xml version="1.0" encoding="utf-8"?>
+<p:sld xmlns:a="http://schemas.openxmlformats.org/drawingml/2006/main" xmlns:p="http://schemas.openxmlformats.org/presentationml/2006/main" xmlns:r="http://schemas.openxmlformats.org/officeDocument/2006/relationships">
+  <p:cSld>
+    <p:spTree>
+      <p:nvGrpSpPr>
+        <p:cNvPr id="1" name=""/>
+        <p:cNvGrpSpPr/>
+        <p:nvPr/>
+      </p:nvGrpSpPr>
+      <p:grpSpPr/>
+      <p:sp>
+        <p:nvSpPr>
+          <p:cNvPr id="2" name="Title 1"/>
+          <p:cNvSpPr>
+            <a:spLocks noGrp="1"/>
+          </p:cNvSpPr>
+          <p:nvPr>
+            <p:ph type="title"/>
+          </p:nvPr>
+        </p:nvSpPr>
+        <p:spPr/>
+        <p:txBody>
+          <a:bodyPr/>
+          <a:lstStyle/>
+          <a:p>
+            <a:r>
+              <a:rPr b="1">
+                <a:solidFill>
+                  <a:srgbClr val="1F4E79"/>
+                </a:solidFill>
+              </a:rPr>
+              <a:t>Meal Signup</a:t>
+            </a:r>
+          </a:p>
+        </p:txBody>
+      </p:sp>
+      <p:sp>
+        <p:nvSpPr>
+          <p:cNvPr id="3" name="Content Placeholder 2"/>
+          <p:cNvSpPr>
+            <a:spLocks noGrp="1"/>
+          </p:cNvSpPr>
+          <p:nvPr>
+            <p:ph idx="1"/>
+          </p:nvPr>
+        </p:nvSpPr>
+        <p:spPr/>
+        <p:txBody>
+          <a:bodyPr/>
+          <a:lstStyle/>
+          <a:p>
+            <a:pPr/>
+            <a:r>
+              <a:t>Signup at www.uparc.org</a:t>
+            </a:r>
+          </a:p>
+          <a:p>
+            <a:pPr/>
+            <a:r>
+              <a:t>Deadline: 11:59 PM June 22</a:t>
+            </a:r>
+          </a:p>
+          <a:p>
+            <a:pPr/>
+            <a:r>
+              <a:t>Required for headcount</a:t>
+            </a:r>
+          </a:p>
+          <a:p>
+            <a:pPr/>
+            <a:r>
+              <a:t>No signup = no guaranteed meal</a:t>
             </a:r>
           </a:p>
         </p:txBody>
@@ -3821,31 +4202,394 @@
           <a:p>
             <a:pPr/>
             <a:r>
-              <a:t>Ham radio's annual “open house” — a public demonstration of amateur radio.</a:t>
-            </a:r>
-          </a:p>
-          <a:p>
-            <a:pPr/>
-            <a:r>
-              <a:t>An exercise in setting up radio communications under less-than-ideal conditions: temporary antennas, generators, portable gear.</a:t>
-            </a:r>
-          </a:p>
-          <a:p>
-            <a:pPr/>
-            <a:r>
-              <a:t>Every June, 40,000+ hams across North America operate from public sites.</a:t>
-            </a:r>
-          </a:p>
-          <a:p>
-            <a:pPr/>
-            <a:r>
-              <a:t>Combines public service, emergency preparedness, community outreach, and technical skill.</a:t>
-            </a:r>
-          </a:p>
-          <a:p>
-            <a:pPr/>
-            <a:r>
-              <a:t>Annual event since 1933 — the most popular event in ham radio.</a:t>
+              <a:t>Ham radio's annual open house</a:t>
+            </a:r>
+          </a:p>
+          <a:p>
+            <a:pPr/>
+            <a:r>
+              <a:t>Set up under field conditions</a:t>
+            </a:r>
+          </a:p>
+          <a:p>
+            <a:pPr/>
+            <a:r>
+              <a:t>40,000+ hams across N. America</a:t>
+            </a:r>
+          </a:p>
+          <a:p>
+            <a:pPr/>
+            <a:r>
+              <a:t>Public service + skill demo</a:t>
+            </a:r>
+          </a:p>
+          <a:p>
+            <a:pPr/>
+            <a:r>
+              <a:t>Annual since 1933</a:t>
+            </a:r>
+          </a:p>
+        </p:txBody>
+      </p:sp>
+    </p:spTree>
+  </p:cSld>
+  <p:clrMapOvr>
+    <a:masterClrMapping/>
+  </p:clrMapOvr>
+</p:sld>
+</file>
+
+<file path=ppt/slides/slide20.xml><?xml version="1.0" encoding="utf-8"?>
+<p:sld xmlns:a="http://schemas.openxmlformats.org/drawingml/2006/main" xmlns:p="http://schemas.openxmlformats.org/presentationml/2006/main" xmlns:r="http://schemas.openxmlformats.org/officeDocument/2006/relationships">
+  <p:cSld>
+    <p:spTree>
+      <p:nvGrpSpPr>
+        <p:cNvPr id="1" name=""/>
+        <p:cNvGrpSpPr/>
+        <p:nvPr/>
+      </p:nvGrpSpPr>
+      <p:grpSpPr/>
+      <p:sp>
+        <p:nvSpPr>
+          <p:cNvPr id="2" name="Title 1"/>
+          <p:cNvSpPr>
+            <a:spLocks noGrp="1"/>
+          </p:cNvSpPr>
+          <p:nvPr>
+            <p:ph type="title"/>
+          </p:nvPr>
+        </p:nvSpPr>
+        <p:spPr/>
+        <p:txBody>
+          <a:bodyPr/>
+          <a:lstStyle/>
+          <a:p>
+            <a:r>
+              <a:rPr b="1">
+                <a:solidFill>
+                  <a:srgbClr val="1F4E79"/>
+                </a:solidFill>
+              </a:rPr>
+              <a:t>Visitors Welcome</a:t>
+            </a:r>
+          </a:p>
+        </p:txBody>
+      </p:sp>
+      <p:sp>
+        <p:nvSpPr>
+          <p:cNvPr id="3" name="Content Placeholder 2"/>
+          <p:cNvSpPr>
+            <a:spLocks noGrp="1"/>
+          </p:cNvSpPr>
+          <p:nvPr>
+            <p:ph idx="1"/>
+          </p:nvPr>
+        </p:nvSpPr>
+        <p:spPr/>
+        <p:txBody>
+          <a:bodyPr/>
+          <a:lstStyle/>
+          <a:p>
+            <a:pPr/>
+            <a:r>
+              <a:t>Field Day is a public event</a:t>
+            </a:r>
+          </a:p>
+          <a:p>
+            <a:pPr/>
+            <a:r>
+              <a:t>Watch the stations operate</a:t>
+            </a:r>
+          </a:p>
+          <a:p>
+            <a:pPr/>
+            <a:r>
+              <a:t>Talk to operators between QSOs</a:t>
+            </a:r>
+          </a:p>
+          <a:p>
+            <a:pPr/>
+            <a:r>
+              <a:t>Ask about licensing</a:t>
+            </a:r>
+          </a:p>
+          <a:p>
+            <a:pPr/>
+            <a:r>
+              <a:t>Education sessions all Saturday</a:t>
+            </a:r>
+          </a:p>
+        </p:txBody>
+      </p:sp>
+    </p:spTree>
+  </p:cSld>
+  <p:clrMapOvr>
+    <a:masterClrMapping/>
+  </p:clrMapOvr>
+</p:sld>
+</file>
+
+<file path=ppt/slides/slide21.xml><?xml version="1.0" encoding="utf-8"?>
+<p:sld xmlns:a="http://schemas.openxmlformats.org/drawingml/2006/main" xmlns:p="http://schemas.openxmlformats.org/presentationml/2006/main" xmlns:r="http://schemas.openxmlformats.org/officeDocument/2006/relationships">
+  <p:cSld>
+    <p:spTree>
+      <p:nvGrpSpPr>
+        <p:cNvPr id="1" name=""/>
+        <p:cNvGrpSpPr/>
+        <p:nvPr/>
+      </p:nvGrpSpPr>
+      <p:grpSpPr/>
+      <p:sp>
+        <p:nvSpPr>
+          <p:cNvPr id="2" name="Title 1"/>
+          <p:cNvSpPr>
+            <a:spLocks noGrp="1"/>
+          </p:cNvSpPr>
+          <p:nvPr>
+            <p:ph type="title"/>
+          </p:nvPr>
+        </p:nvSpPr>
+        <p:spPr/>
+        <p:txBody>
+          <a:bodyPr/>
+          <a:lstStyle/>
+          <a:p>
+            <a:r>
+              <a:rPr b="1">
+                <a:solidFill>
+                  <a:srgbClr val="1F4E79"/>
+                </a:solidFill>
+              </a:rPr>
+              <a:t>Members — Get Involved</a:t>
+            </a:r>
+          </a:p>
+        </p:txBody>
+      </p:sp>
+      <p:sp>
+        <p:nvSpPr>
+          <p:cNvPr id="3" name="Content Placeholder 2"/>
+          <p:cNvSpPr>
+            <a:spLocks noGrp="1"/>
+          </p:cNvSpPr>
+          <p:nvPr>
+            <p:ph idx="1"/>
+          </p:nvPr>
+        </p:nvSpPr>
+        <p:spPr/>
+        <p:txBody>
+          <a:bodyPr/>
+          <a:lstStyle/>
+          <a:p>
+            <a:pPr/>
+            <a:r>
+              <a:t>Sign up for meals by June 22</a:t>
+            </a:r>
+          </a:p>
+          <a:p>
+            <a:pPr/>
+            <a:r>
+              <a:t>Attend the dry-run June 20</a:t>
+            </a:r>
+          </a:p>
+          <a:p>
+            <a:pPr/>
+            <a:r>
+              <a:t>Help setup Sat 8:00 AM</a:t>
+            </a:r>
+          </a:p>
+          <a:p>
+            <a:pPr/>
+            <a:r>
+              <a:t>Help teardown Sun 2:00 PM</a:t>
+            </a:r>
+          </a:p>
+          <a:p>
+            <a:pPr/>
+            <a:r>
+              <a:t>New operators paired with veterans</a:t>
+            </a:r>
+          </a:p>
+          <a:p>
+            <a:pPr/>
+            <a:r>
+              <a:t>Bring your own wired headset</a:t>
+            </a:r>
+          </a:p>
+        </p:txBody>
+      </p:sp>
+    </p:spTree>
+  </p:cSld>
+  <p:clrMapOvr>
+    <a:masterClrMapping/>
+  </p:clrMapOvr>
+</p:sld>
+</file>
+
+<file path=ppt/slides/slide22.xml><?xml version="1.0" encoding="utf-8"?>
+<p:sld xmlns:a="http://schemas.openxmlformats.org/drawingml/2006/main" xmlns:p="http://schemas.openxmlformats.org/presentationml/2006/main" xmlns:r="http://schemas.openxmlformats.org/officeDocument/2006/relationships">
+  <p:cSld>
+    <p:spTree>
+      <p:nvGrpSpPr>
+        <p:cNvPr id="1" name=""/>
+        <p:cNvGrpSpPr/>
+        <p:nvPr/>
+      </p:nvGrpSpPr>
+      <p:grpSpPr/>
+      <p:sp>
+        <p:nvSpPr>
+          <p:cNvPr id="2" name="Title 1"/>
+          <p:cNvSpPr>
+            <a:spLocks noGrp="1"/>
+          </p:cNvSpPr>
+          <p:nvPr>
+            <p:ph type="title"/>
+          </p:nvPr>
+        </p:nvSpPr>
+        <p:spPr/>
+        <p:txBody>
+          <a:bodyPr/>
+          <a:lstStyle/>
+          <a:p>
+            <a:r>
+              <a:rPr b="1">
+                <a:solidFill>
+                  <a:srgbClr val="1F4E79"/>
+                </a:solidFill>
+              </a:rPr>
+              <a:t>Operating Etiquette</a:t>
+            </a:r>
+          </a:p>
+        </p:txBody>
+      </p:sp>
+      <p:sp>
+        <p:nvSpPr>
+          <p:cNvPr id="3" name="Content Placeholder 2"/>
+          <p:cNvSpPr>
+            <a:spLocks noGrp="1"/>
+          </p:cNvSpPr>
+          <p:nvPr>
+            <p:ph idx="1"/>
+          </p:nvPr>
+        </p:nvSpPr>
+        <p:spPr/>
+        <p:txBody>
+          <a:bodyPr/>
+          <a:lstStyle/>
+          <a:p>
+            <a:pPr/>
+            <a:r>
+              <a:t>OPON when starting your shift</a:t>
+            </a:r>
+          </a:p>
+          <a:p>
+            <a:pPr/>
+            <a:r>
+              <a:t>Listen before calling</a:t>
+            </a:r>
+          </a:p>
+          <a:p>
+            <a:pPr/>
+            <a:r>
+              <a:t>Log every QSO immediately</a:t>
+            </a:r>
+          </a:p>
+          <a:p>
+            <a:pPr/>
+            <a:r>
+              <a:t>Check your station card first</a:t>
+            </a:r>
+          </a:p>
+          <a:p>
+            <a:pPr/>
+            <a:r>
+              <a:t>Have fun</a:t>
+            </a:r>
+          </a:p>
+        </p:txBody>
+      </p:sp>
+    </p:spTree>
+  </p:cSld>
+  <p:clrMapOvr>
+    <a:masterClrMapping/>
+  </p:clrMapOvr>
+</p:sld>
+</file>
+
+<file path=ppt/slides/slide23.xml><?xml version="1.0" encoding="utf-8"?>
+<p:sld xmlns:a="http://schemas.openxmlformats.org/drawingml/2006/main" xmlns:p="http://schemas.openxmlformats.org/presentationml/2006/main" xmlns:r="http://schemas.openxmlformats.org/officeDocument/2006/relationships">
+  <p:cSld>
+    <p:spTree>
+      <p:nvGrpSpPr>
+        <p:cNvPr id="1" name=""/>
+        <p:cNvGrpSpPr/>
+        <p:nvPr/>
+      </p:nvGrpSpPr>
+      <p:grpSpPr/>
+      <p:sp>
+        <p:nvSpPr>
+          <p:cNvPr id="2" name="Title 1"/>
+          <p:cNvSpPr>
+            <a:spLocks noGrp="1"/>
+          </p:cNvSpPr>
+          <p:nvPr>
+            <p:ph type="title"/>
+          </p:nvPr>
+        </p:nvSpPr>
+        <p:spPr/>
+        <p:txBody>
+          <a:bodyPr/>
+          <a:lstStyle/>
+          <a:p>
+            <a:r>
+              <a:rPr b="1" sz="6000">
+                <a:solidFill>
+                  <a:srgbClr val="1F4E79"/>
+                </a:solidFill>
+              </a:rPr>
+              <a:t>Q &amp; A</a:t>
+            </a:r>
+          </a:p>
+        </p:txBody>
+      </p:sp>
+      <p:sp>
+        <p:nvSpPr>
+          <p:cNvPr id="3" name="TextBox 2"/>
+          <p:cNvSpPr txBox="1"/>
+          <p:nvPr/>
+        </p:nvSpPr>
+        <p:spPr>
+          <a:xfrm>
+            <a:off x="914400" y="3657600"/>
+            <a:ext cx="10360152" cy="1828800"/>
+          </a:xfrm>
+          <a:prstGeom prst="rect">
+            <a:avLst/>
+          </a:prstGeom>
+          <a:noFill/>
+        </p:spPr>
+        <p:txBody>
+          <a:bodyPr wrap="none">
+            <a:spAutoFit/>
+          </a:bodyPr>
+          <a:lstStyle/>
+          <a:p>
+            <a:r>
+              <a:rPr i="1" sz="2800">
+                <a:solidFill>
+                  <a:srgbClr val="555555"/>
+                </a:solidFill>
+              </a:rPr>
+              <a:t>Questions?  Concerns?  Volunteers?</a:t>
+            </a:r>
+          </a:p>
+          <a:p>
+            <a:r>
+              <a:rPr sz="1800">
+                <a:solidFill>
+                  <a:srgbClr val="555555"/>
+                </a:solidFill>
+              </a:rPr>
+              <a:t>Section leads — Ryan AF4O · Fred W2SUB · Tom NY4I · Paul KC4YDY · Ron W4RFA</a:t>
             </a:r>
           </a:p>
         </p:txBody>
@@ -3911,31 +4655,31 @@
           <a:p>
             <a:pPr/>
             <a:r>
-              <a:t>Preparedness: prove we can stand up working stations from scratch when normal infrastructure isn’t available.</a:t>
-            </a:r>
-          </a:p>
-          <a:p>
-            <a:pPr/>
-            <a:r>
-              <a:t>Skill: practice operating in pile-ups, on every band and mode we have antennas for.</a:t>
-            </a:r>
-          </a:p>
-          <a:p>
-            <a:pPr/>
-            <a:r>
-              <a:t>Community: four clubs (UPARC, SPARC, WORMs, CARS) working a single event.</a:t>
-            </a:r>
-          </a:p>
-          <a:p>
-            <a:pPr/>
-            <a:r>
-              <a:t>Outreach: visitors welcome — Field Day is a great place to see ham radio in action.</a:t>
-            </a:r>
-          </a:p>
-          <a:p>
-            <a:pPr/>
-            <a:r>
-              <a:t>Fun: a 24-hour contest with friends, food, and a lot of QSOs.</a:t>
+              <a:t>Preparedness — deploy on demand</a:t>
+            </a:r>
+          </a:p>
+          <a:p>
+            <a:pPr/>
+            <a:r>
+              <a:t>Skill — pile-ups on every band</a:t>
+            </a:r>
+          </a:p>
+          <a:p>
+            <a:pPr/>
+            <a:r>
+              <a:t>Community — four clubs, one event</a:t>
+            </a:r>
+          </a:p>
+          <a:p>
+            <a:pPr/>
+            <a:r>
+              <a:t>Outreach — visitors welcome</a:t>
+            </a:r>
+          </a:p>
+          <a:p>
+            <a:pPr/>
+            <a:r>
+              <a:t>Fun — 24 hours of QSOs</a:t>
             </a:r>
           </a:p>
         </p:txBody>
@@ -3979,7 +4723,7 @@
                   <a:srgbClr val="1F4E79"/>
                 </a:solidFill>
               </a:rPr>
-              <a:t>When, Where &amp; Schedule</a:t>
+              <a:t>When &amp; Where</a:t>
             </a:r>
           </a:p>
         </p:txBody>
@@ -4001,61 +4745,31 @@
           <a:p>
             <a:pPr/>
             <a:r>
-              <a:t>Where: Clearwater Fire Station #48</a:t>
-            </a:r>
-          </a:p>
-          <a:p>
-            <a:pPr lvl="1"/>
-            <a:r>
-              <a:t>1700 N Belcher Rd., Clearwater, FL 33765</a:t>
-            </a:r>
-          </a:p>
-          <a:p>
-            <a:pPr/>
-            <a:r>
-              <a:t>When: June 27–28, 2026 (Saturday – Sunday)</a:t>
-            </a:r>
-          </a:p>
-          <a:p>
-            <a:pPr lvl="1"/>
-            <a:r>
-              <a:t>Setup begins: 8:00 AM Saturday, June 27 (lunch around noon)</a:t>
-            </a:r>
-          </a:p>
-          <a:p>
-            <a:pPr lvl="1"/>
-            <a:r>
-              <a:t>Operating begins: 2:00 PM Saturday, June 27</a:t>
-            </a:r>
-          </a:p>
-          <a:p>
-            <a:pPr lvl="1"/>
-            <a:r>
-              <a:t>Operating ends / teardown: 2:00 PM Sunday, June 28</a:t>
-            </a:r>
-          </a:p>
-          <a:p>
-            <a:pPr/>
-            <a:r>
-              <a:t>ARRL Class: 3A  (three simultaneous transmitters, portable/club)</a:t>
-            </a:r>
-          </a:p>
-          <a:p>
-            <a:pPr/>
-            <a:r>
-              <a:t>Operation is indoors (except the Satellite station).</a:t>
-            </a:r>
-          </a:p>
-          <a:p>
-            <a:pPr/>
-            <a:r>
-              <a:t>Dry-run: Saturday June 20, 9:00 AM, Clearwater Fire Training Center</a:t>
-            </a:r>
-          </a:p>
-          <a:p>
-            <a:pPr/>
-            <a:r>
-              <a:t>Meal signup: www.uparc.org — by June 22 at 11:59 PM</a:t>
+              <a:t>June 27–28, 2026 (Sat – Sun)</a:t>
+            </a:r>
+          </a:p>
+          <a:p>
+            <a:pPr/>
+            <a:r>
+              <a:t>Clearwater Fire Station #48</a:t>
+            </a:r>
+          </a:p>
+          <a:p>
+            <a:pPr/>
+            <a:r>
+              <a:t>1700 N Belcher Rd., Clearwater, FL</a:t>
+            </a:r>
+          </a:p>
+          <a:p>
+            <a:pPr/>
+            <a:r>
+              <a:t>Indoors (except Satellite)</a:t>
+            </a:r>
+          </a:p>
+          <a:p>
+            <a:pPr/>
+            <a:r>
+              <a:t>ARRL Class: 3A</a:t>
             </a:r>
           </a:p>
         </p:txBody>
@@ -4099,7 +4813,7 @@
                   <a:srgbClr val="1F4E79"/>
                 </a:solidFill>
               </a:rPr>
-              <a:t>Operating Modes &amp; Bands</a:t>
+              <a:t>Schedule</a:t>
             </a:r>
           </a:p>
         </p:txBody>
@@ -4121,25 +4835,37 @@
           <a:p>
             <a:pPr/>
             <a:r>
-              <a:t>Modes: CW, SSB, FT8 (digital)</a:t>
-            </a:r>
-          </a:p>
-          <a:p>
-            <a:pPr/>
-            <a:r>
-              <a:t>Bands: 6 m – 80 m</a:t>
-            </a:r>
-          </a:p>
-          <a:p>
-            <a:pPr/>
-            <a:r>
-              <a:t>Each station has a primary mode; other modes available if conditions dictate.</a:t>
-            </a:r>
-          </a:p>
-          <a:p>
-            <a:pPr/>
-            <a:r>
-              <a:t>Bring your own headset/mic gear (3.5 mm or 1/4 in plug). We do not share headphones or mic headsets for sanitary reasons.</a:t>
+              <a:t>Setup: 8:00 AM Sat June 27</a:t>
+            </a:r>
+          </a:p>
+          <a:p>
+            <a:pPr/>
+            <a:r>
+              <a:t>Lunch: around noon</a:t>
+            </a:r>
+          </a:p>
+          <a:p>
+            <a:pPr/>
+            <a:r>
+              <a:t>Operating: 2:00 PM Sat → 2:00 PM Sun</a:t>
+            </a:r>
+          </a:p>
+          <a:p>
+            <a:pPr/>
+            <a:r>
+              <a:t>Teardown: 2:00 PM Sun June 28</a:t>
+            </a:r>
+          </a:p>
+          <a:p>
+            <a:pPr/>
+            <a:r>
+              <a:t>Dry-run: 9:00 AM Sat June 20</a:t>
+            </a:r>
+          </a:p>
+          <a:p>
+            <a:pPr/>
+            <a:r>
+              <a:t>Dry-run at Clearwater Fire Training Center</a:t>
             </a:r>
           </a:p>
         </p:txBody>
@@ -4178,45 +4904,64 @@
           <a:lstStyle/>
           <a:p>
             <a:r>
-              <a:rPr b="1" sz="4400">
+              <a:rPr b="1">
                 <a:solidFill>
                   <a:srgbClr val="1F4E79"/>
                 </a:solidFill>
               </a:rPr>
-              <a:t>Station Lineup</a:t>
-            </a:r>
-          </a:p>
-        </p:txBody>
-      </p:sp>
-      <p:sp>
-        <p:nvSpPr>
-          <p:cNvPr id="3" name="TextBox 2"/>
-          <p:cNvSpPr txBox="1"/>
-          <p:nvPr/>
-        </p:nvSpPr>
-        <p:spPr>
-          <a:xfrm>
-            <a:off x="914400" y="3657600"/>
-            <a:ext cx="10360152" cy="914400"/>
-          </a:xfrm>
-          <a:prstGeom prst="rect">
-            <a:avLst/>
-          </a:prstGeom>
-          <a:noFill/>
-        </p:spPr>
-        <p:txBody>
-          <a:bodyPr wrap="none">
-            <a:spAutoFit/>
-          </a:bodyPr>
-          <a:lstStyle/>
-          <a:p>
-            <a:r>
-              <a:rPr i="1" sz="2400">
-                <a:solidFill>
-                  <a:srgbClr val="555555"/>
-                </a:solidFill>
-              </a:rPr>
-              <a:t>Three HF positions + one VHF position + Talk-In + Satellite</a:t>
+              <a:t>Operating Modes &amp; Bands</a:t>
+            </a:r>
+          </a:p>
+        </p:txBody>
+      </p:sp>
+      <p:sp>
+        <p:nvSpPr>
+          <p:cNvPr id="3" name="Content Placeholder 2"/>
+          <p:cNvSpPr>
+            <a:spLocks noGrp="1"/>
+          </p:cNvSpPr>
+          <p:nvPr>
+            <p:ph idx="1"/>
+          </p:nvPr>
+        </p:nvSpPr>
+        <p:spPr/>
+        <p:txBody>
+          <a:bodyPr/>
+          <a:lstStyle/>
+          <a:p>
+            <a:pPr/>
+            <a:r>
+              <a:t>Modes: CW · SSB · FT8</a:t>
+            </a:r>
+          </a:p>
+          <a:p>
+            <a:pPr/>
+            <a:r>
+              <a:t>Bands: 6 m through 80 m</a:t>
+            </a:r>
+          </a:p>
+          <a:p>
+            <a:pPr/>
+            <a:r>
+              <a:t>Each station has a primary mode</a:t>
+            </a:r>
+          </a:p>
+          <a:p>
+            <a:pPr/>
+            <a:r>
+              <a:t>Other modes if conditions allow</a:t>
+            </a:r>
+          </a:p>
+          <a:p>
+            <a:pPr/>
+            <a:r>
+              <a:t>Bring your own wired headset</a:t>
+            </a:r>
+          </a:p>
+          <a:p>
+            <a:pPr/>
+            <a:r>
+              <a:t>3.5 mm or 1/4 inch plug</a:t>
             </a:r>
           </a:p>
         </p:txBody>
@@ -4255,82 +5000,45 @@
           <a:lstStyle/>
           <a:p>
             <a:r>
-              <a:rPr b="1">
+              <a:rPr b="1" sz="4400">
                 <a:solidFill>
                   <a:srgbClr val="1F4E79"/>
                 </a:solidFill>
               </a:rPr>
-              <a:t>Stations</a:t>
-            </a:r>
-          </a:p>
-        </p:txBody>
-      </p:sp>
-      <p:sp>
-        <p:nvSpPr>
-          <p:cNvPr id="3" name="Content Placeholder 2"/>
-          <p:cNvSpPr>
-            <a:spLocks noGrp="1"/>
-          </p:cNvSpPr>
-          <p:nvPr>
-            <p:ph idx="1"/>
-          </p:nvPr>
-        </p:nvSpPr>
-        <p:spPr/>
-        <p:txBody>
-          <a:bodyPr/>
-          <a:lstStyle/>
-          <a:p>
-            <a:pPr/>
-            <a:r>
-              <a:t>Station 1 — Elecraft K4 (SSB)</a:t>
-            </a:r>
-          </a:p>
-          <a:p>
-            <a:pPr lvl="1"/>
-            <a:r>
-              <a:t>K4’s CESSB feature gives ~6–8 dB of extra effective talk power. Single K4 used on SSB.</a:t>
-            </a:r>
-          </a:p>
-          <a:p>
-            <a:pPr/>
-            <a:r>
-              <a:t>Station 2 — Elecraft K3S (SSB / Digital incl. FT8)</a:t>
-            </a:r>
-          </a:p>
-          <a:p>
-            <a:pPr lvl="1"/>
-            <a:r>
-              <a:t>Adds an external VGA monitor for digital-mode waterfall and decoders.</a:t>
-            </a:r>
-          </a:p>
-          <a:p>
-            <a:pPr/>
-            <a:r>
-              <a:t>Station 3 — Elecraft K3 (CW)</a:t>
-            </a:r>
-          </a:p>
-          <a:p>
-            <a:pPr lvl="1"/>
-            <a:r>
-              <a:t>WinKey Mini + Bencher paddle (supplied by NY4I). Also runs SSB / Digital if needed.</a:t>
-            </a:r>
-          </a:p>
-          <a:p>
-            <a:pPr/>
-            <a:r>
-              <a:t>VHF Station — Yaesu FT-897 (6 m)</a:t>
-            </a:r>
-          </a:p>
-          <a:p>
-            <a:pPr lvl="1"/>
-            <a:r>
-              <a:t>Brought and operated by Paul KC4YDY.</a:t>
-            </a:r>
-          </a:p>
-          <a:p>
-            <a:pPr/>
-            <a:r>
-              <a:t>Talk-In Station — informational, not on the logging network.</a:t>
+              <a:t>Station Lineup</a:t>
+            </a:r>
+          </a:p>
+        </p:txBody>
+      </p:sp>
+      <p:sp>
+        <p:nvSpPr>
+          <p:cNvPr id="3" name="TextBox 2"/>
+          <p:cNvSpPr txBox="1"/>
+          <p:nvPr/>
+        </p:nvSpPr>
+        <p:spPr>
+          <a:xfrm>
+            <a:off x="914400" y="3657600"/>
+            <a:ext cx="10360152" cy="914400"/>
+          </a:xfrm>
+          <a:prstGeom prst="rect">
+            <a:avLst/>
+          </a:prstGeom>
+          <a:noFill/>
+        </p:spPr>
+        <p:txBody>
+          <a:bodyPr wrap="none">
+            <a:spAutoFit/>
+          </a:bodyPr>
+          <a:lstStyle/>
+          <a:p>
+            <a:r>
+              <a:rPr i="1" sz="2400">
+                <a:solidFill>
+                  <a:srgbClr val="555555"/>
+                </a:solidFill>
+              </a:rPr>
+              <a:t>Three HF positions + VHF + Satellite</a:t>
             </a:r>
           </a:p>
         </p:txBody>
@@ -4374,7 +5082,7 @@
                   <a:srgbClr val="1F4E79"/>
                 </a:solidFill>
               </a:rPr>
-              <a:t>Logging Network &amp; Stats</a:t>
+              <a:t>Station 1 — Elecraft K4</a:t>
             </a:r>
           </a:p>
         </p:txBody>
@@ -4394,67 +5102,33 @@
           <a:bodyPr/>
           <a:lstStyle/>
           <a:p>
-            <a:r>
-              <a:rPr i="1" sz="1600">
-                <a:solidFill>
-                  <a:srgbClr val="555555"/>
-                </a:solidFill>
-              </a:rPr>
-              <a:t>Tom NY4I</a:t>
-            </a:r>
-          </a:p>
-          <a:p>
-            <a:pPr/>
-            <a:r>
-              <a:t>All HF stations run TR4W (Windows logger) on their laptops.</a:t>
-            </a:r>
-          </a:p>
-          <a:p>
-            <a:pPr/>
-            <a:r>
-              <a:t>Laptops join the TRLOG WiFi (10.0.0.0/24) via the Linksys router.</a:t>
-            </a:r>
-          </a:p>
-          <a:p>
-            <a:pPr/>
-            <a:r>
-              <a:t>Raspberry Pi 400 (wired Ethernet, 192.168.0.100) is the server:</a:t>
-            </a:r>
-          </a:p>
-          <a:p>
-            <a:pPr lvl="1"/>
-            <a:r>
-              <a:t>TR4W Server (Python) — multi-op duplicate checks across stations.</a:t>
-            </a:r>
-          </a:p>
-          <a:p>
-            <a:pPr lvl="1"/>
-            <a:r>
-              <a:t>n1mm_view — generates stats images (band/score/rate) on a RAM disk.</a:t>
-            </a:r>
-          </a:p>
-          <a:p>
-            <a:pPr lvl="1"/>
-            <a:r>
-              <a:t>Local web UI on :8080 — viewable on the on-site HDMI monitor.</a:t>
-            </a:r>
-          </a:p>
-          <a:p>
-            <a:pPr lvl="1"/>
-            <a:r>
-              <a:t>rsync publisher — pushes stats images to UPARC and SPARC websites.</a:t>
-            </a:r>
-          </a:p>
-          <a:p>
-            <a:pPr/>
-            <a:r>
-              <a:t>Pi 400 + Linksys router are both protected by a UPS.</a:t>
-            </a:r>
-          </a:p>
-          <a:p>
-            <a:pPr/>
-            <a:r>
-              <a:t>Replaces the old Windows TR4W Server box — single Pi handles everything now.</a:t>
+            <a:pPr/>
+            <a:r>
+              <a:t>Primary mode: SSB</a:t>
+            </a:r>
+          </a:p>
+          <a:p>
+            <a:pPr/>
+            <a:r>
+              <a:t>Native USB to laptop</a:t>
+            </a:r>
+          </a:p>
+          <a:p>
+            <a:pPr/>
+            <a:r>
+              <a:t>CESSB feature: 6–8 dB extra TX</a:t>
+            </a:r>
+          </a:p>
+          <a:p>
+            <a:pPr/>
+            <a:r>
+              <a:t>Best single-rig use is SSB</a:t>
+            </a:r>
+          </a:p>
+          <a:p>
+            <a:pPr/>
+            <a:r>
+              <a:t>InRad mic; Heil adapter optional</a:t>
             </a:r>
           </a:p>
         </p:txBody>
@@ -4498,7 +5172,7 @@
                   <a:srgbClr val="1F4E79"/>
                 </a:solidFill>
               </a:rPr>
-              <a:t>Antennas &amp; Patch Panel</a:t>
+              <a:t>Station 2 — Elecraft K3S</a:t>
             </a:r>
           </a:p>
         </p:txBody>
@@ -4518,37 +5192,33 @@
           <a:bodyPr/>
           <a:lstStyle/>
           <a:p>
-            <a:r>
-              <a:rPr i="1" sz="1600">
-                <a:solidFill>
-                  <a:srgbClr val="555555"/>
-                </a:solidFill>
-              </a:rPr>
-              <a:t>Ryan AF4O</a:t>
-            </a:r>
-          </a:p>
-          <a:p>
-            <a:pPr/>
-            <a:r>
-              <a:t>All antenna feedlines come back to a portable patch panel in the radio room.</a:t>
-            </a:r>
-          </a:p>
-          <a:p>
-            <a:pPr/>
-            <a:r>
-              <a:t>Radios are connected to specific antennas through this patch panel.</a:t>
-            </a:r>
-          </a:p>
-          <a:p>
-            <a:pPr/>
-            <a:r>
-              <a:t>Do NOT change coax routing without approval from the assigned Band Boss.</a:t>
-            </a:r>
-          </a:p>
-          <a:p>
-            <a:pPr/>
-            <a:r>
-              <a:t>Station 3 (CW) uses a 65 ft RG-8X coax run around the room (east wall, top wall) to reach the patch panel.</a:t>
+            <a:pPr/>
+            <a:r>
+              <a:t>Primary mode: FT8 / digital</a:t>
+            </a:r>
+          </a:p>
+          <a:p>
+            <a:pPr/>
+            <a:r>
+              <a:t>External VGA monitor for waterfall</a:t>
+            </a:r>
+          </a:p>
+          <a:p>
+            <a:pPr/>
+            <a:r>
+              <a:t>DB9-to-USB adapter to laptop</a:t>
+            </a:r>
+          </a:p>
+          <a:p>
+            <a:pPr/>
+            <a:r>
+              <a:t>Also capable of SSB</a:t>
+            </a:r>
+          </a:p>
+          <a:p>
+            <a:pPr/>
+            <a:r>
+              <a:t>InRad mic; Heil adapter optional</a:t>
             </a:r>
           </a:p>
         </p:txBody>

</xml_diff>